<commit_message>
Add & update blueprint pdfs
</commit_message>
<xml_diff>
--- a/Blueprint/UseCases_PersistenID.pptx
+++ b/Blueprint/UseCases_PersistenID.pptx
@@ -18,6 +18,7 @@
     <p:sldId id="276" r:id="rId12"/>
     <p:sldId id="277" r:id="rId13"/>
     <p:sldId id="278" r:id="rId14"/>
+    <p:sldId id="280" r:id="rId15"/>
   </p:sldIdLst>
   <p:sldSz cx="12192000" cy="6858000"/>
   <p:notesSz cx="6858000" cy="9144000"/>
@@ -992,7 +993,7 @@
           <a:p>
             <a:fld id="{29BFE5FB-EE99-4E69-B2F7-C156D52DE4BD}" type="datetimeFigureOut">
               <a:rPr lang="en-GB" smtClean="0"/>
-              <a:t>25/09/2025</a:t>
+              <a:t>09/10/2025</a:t>
             </a:fld>
             <a:endParaRPr lang="en-GB"/>
           </a:p>
@@ -1192,7 +1193,7 @@
           <a:p>
             <a:fld id="{29BFE5FB-EE99-4E69-B2F7-C156D52DE4BD}" type="datetimeFigureOut">
               <a:rPr lang="en-GB" smtClean="0"/>
-              <a:t>25/09/2025</a:t>
+              <a:t>09/10/2025</a:t>
             </a:fld>
             <a:endParaRPr lang="en-GB"/>
           </a:p>
@@ -1402,7 +1403,7 @@
           <a:p>
             <a:fld id="{29BFE5FB-EE99-4E69-B2F7-C156D52DE4BD}" type="datetimeFigureOut">
               <a:rPr lang="en-GB" smtClean="0"/>
-              <a:t>25/09/2025</a:t>
+              <a:t>09/10/2025</a:t>
             </a:fld>
             <a:endParaRPr lang="en-GB"/>
           </a:p>
@@ -1602,7 +1603,7 @@
           <a:p>
             <a:fld id="{29BFE5FB-EE99-4E69-B2F7-C156D52DE4BD}" type="datetimeFigureOut">
               <a:rPr lang="en-GB" smtClean="0"/>
-              <a:t>25/09/2025</a:t>
+              <a:t>09/10/2025</a:t>
             </a:fld>
             <a:endParaRPr lang="en-GB"/>
           </a:p>
@@ -1878,7 +1879,7 @@
           <a:p>
             <a:fld id="{29BFE5FB-EE99-4E69-B2F7-C156D52DE4BD}" type="datetimeFigureOut">
               <a:rPr lang="en-GB" smtClean="0"/>
-              <a:t>25/09/2025</a:t>
+              <a:t>09/10/2025</a:t>
             </a:fld>
             <a:endParaRPr lang="en-GB"/>
           </a:p>
@@ -2146,7 +2147,7 @@
           <a:p>
             <a:fld id="{29BFE5FB-EE99-4E69-B2F7-C156D52DE4BD}" type="datetimeFigureOut">
               <a:rPr lang="en-GB" smtClean="0"/>
-              <a:t>25/09/2025</a:t>
+              <a:t>09/10/2025</a:t>
             </a:fld>
             <a:endParaRPr lang="en-GB"/>
           </a:p>
@@ -2561,7 +2562,7 @@
           <a:p>
             <a:fld id="{29BFE5FB-EE99-4E69-B2F7-C156D52DE4BD}" type="datetimeFigureOut">
               <a:rPr lang="en-GB" smtClean="0"/>
-              <a:t>25/09/2025</a:t>
+              <a:t>09/10/2025</a:t>
             </a:fld>
             <a:endParaRPr lang="en-GB"/>
           </a:p>
@@ -2703,7 +2704,7 @@
           <a:p>
             <a:fld id="{29BFE5FB-EE99-4E69-B2F7-C156D52DE4BD}" type="datetimeFigureOut">
               <a:rPr lang="en-GB" smtClean="0"/>
-              <a:t>25/09/2025</a:t>
+              <a:t>09/10/2025</a:t>
             </a:fld>
             <a:endParaRPr lang="en-GB"/>
           </a:p>
@@ -2816,7 +2817,7 @@
           <a:p>
             <a:fld id="{29BFE5FB-EE99-4E69-B2F7-C156D52DE4BD}" type="datetimeFigureOut">
               <a:rPr lang="en-GB" smtClean="0"/>
-              <a:t>25/09/2025</a:t>
+              <a:t>09/10/2025</a:t>
             </a:fld>
             <a:endParaRPr lang="en-GB"/>
           </a:p>
@@ -3129,7 +3130,7 @@
           <a:p>
             <a:fld id="{29BFE5FB-EE99-4E69-B2F7-C156D52DE4BD}" type="datetimeFigureOut">
               <a:rPr lang="en-GB" smtClean="0"/>
-              <a:t>25/09/2025</a:t>
+              <a:t>09/10/2025</a:t>
             </a:fld>
             <a:endParaRPr lang="en-GB"/>
           </a:p>
@@ -3418,7 +3419,7 @@
           <a:p>
             <a:fld id="{29BFE5FB-EE99-4E69-B2F7-C156D52DE4BD}" type="datetimeFigureOut">
               <a:rPr lang="en-GB" smtClean="0"/>
-              <a:t>25/09/2025</a:t>
+              <a:t>09/10/2025</a:t>
             </a:fld>
             <a:endParaRPr lang="en-GB"/>
           </a:p>
@@ -3661,7 +3662,7 @@
           <a:p>
             <a:fld id="{29BFE5FB-EE99-4E69-B2F7-C156D52DE4BD}" type="datetimeFigureOut">
               <a:rPr lang="en-GB" smtClean="0"/>
-              <a:t>25/09/2025</a:t>
+              <a:t>09/10/2025</a:t>
             </a:fld>
             <a:endParaRPr lang="en-GB"/>
           </a:p>
@@ -5122,51 +5123,12 @@
           <a:chExt cx="0" cy="0"/>
         </a:xfrm>
       </p:grpSpPr>
-      <p:sp>
-        <p:nvSpPr>
-          <p:cNvPr id="3" name="TextBox 2">
-            <a:extLst>
-              <a:ext uri="{FF2B5EF4-FFF2-40B4-BE49-F238E27FC236}">
-                <a16:creationId xmlns:a16="http://schemas.microsoft.com/office/drawing/2014/main" id="{7F5AFCD7-CF64-A7F6-B02F-987454D53E76}"/>
-              </a:ext>
-            </a:extLst>
-          </p:cNvPr>
-          <p:cNvSpPr txBox="1"/>
-          <p:nvPr/>
-        </p:nvSpPr>
-        <p:spPr>
-          <a:xfrm>
-            <a:off x="124051" y="102889"/>
-            <a:ext cx="11607874" cy="369332"/>
-          </a:xfrm>
-          <a:prstGeom prst="rect">
-            <a:avLst/>
-          </a:prstGeom>
-          <a:noFill/>
-        </p:spPr>
-        <p:txBody>
-          <a:bodyPr wrap="square">
-            <a:spAutoFit/>
-          </a:bodyPr>
-          <a:lstStyle/>
-          <a:p>
-            <a:pPr marL="342900" indent="-342900">
-              <a:buFont typeface="+mj-lt"/>
-              <a:buAutoNum type="arabicPeriod" startAt="9"/>
-            </a:pPr>
-            <a:r>
-              <a:rPr lang="en-GB" dirty="0"/>
-              <a:t>Scale D-20HA001 symbol y-axis scaling 1.25 </a:t>
-            </a:r>
-          </a:p>
-        </p:txBody>
-      </p:sp>
       <p:pic>
         <p:nvPicPr>
-          <p:cNvPr id="9" name="Picture 8">
-            <a:extLst>
-              <a:ext uri="{FF2B5EF4-FFF2-40B4-BE49-F238E27FC236}">
-                <a16:creationId xmlns:a16="http://schemas.microsoft.com/office/drawing/2014/main" id="{DAA3EFFF-C56B-6CE0-F69F-364BC8F782E0}"/>
+          <p:cNvPr id="6" name="Picture 5">
+            <a:extLst>
+              <a:ext uri="{FF2B5EF4-FFF2-40B4-BE49-F238E27FC236}">
+                <a16:creationId xmlns:a16="http://schemas.microsoft.com/office/drawing/2014/main" id="{458B31A0-581B-67A9-2076-A070EDB4EF2F}"/>
               </a:ext>
             </a:extLst>
           </p:cNvPr>
@@ -5183,8 +5145,8 @@
         </p:blipFill>
         <p:spPr>
           <a:xfrm>
-            <a:off x="458251" y="914288"/>
-            <a:ext cx="8895299" cy="5410312"/>
+            <a:off x="458251" y="914289"/>
+            <a:ext cx="8895299" cy="5428122"/>
           </a:xfrm>
           <a:prstGeom prst="rect">
             <a:avLst/>
@@ -5196,6 +5158,45 @@
           </a:ln>
         </p:spPr>
       </p:pic>
+      <p:sp>
+        <p:nvSpPr>
+          <p:cNvPr id="3" name="TextBox 2">
+            <a:extLst>
+              <a:ext uri="{FF2B5EF4-FFF2-40B4-BE49-F238E27FC236}">
+                <a16:creationId xmlns:a16="http://schemas.microsoft.com/office/drawing/2014/main" id="{7F5AFCD7-CF64-A7F6-B02F-987454D53E76}"/>
+              </a:ext>
+            </a:extLst>
+          </p:cNvPr>
+          <p:cNvSpPr txBox="1"/>
+          <p:nvPr/>
+        </p:nvSpPr>
+        <p:spPr>
+          <a:xfrm>
+            <a:off x="124051" y="102889"/>
+            <a:ext cx="11607874" cy="369332"/>
+          </a:xfrm>
+          <a:prstGeom prst="rect">
+            <a:avLst/>
+          </a:prstGeom>
+          <a:noFill/>
+        </p:spPr>
+        <p:txBody>
+          <a:bodyPr wrap="square">
+            <a:spAutoFit/>
+          </a:bodyPr>
+          <a:lstStyle/>
+          <a:p>
+            <a:pPr marL="342900" indent="-342900">
+              <a:buFont typeface="+mj-lt"/>
+              <a:buAutoNum type="arabicPeriod" startAt="9"/>
+            </a:pPr>
+            <a:r>
+              <a:rPr lang="en-GB" dirty="0"/>
+              <a:t>Scale D-20HA001 symbol y-axis scaling 1.25 </a:t>
+            </a:r>
+          </a:p>
+        </p:txBody>
+      </p:sp>
     </p:spTree>
     <p:extLst>
       <p:ext uri="{BB962C8B-B14F-4D97-AF65-F5344CB8AC3E}">
@@ -5374,10 +5375,10 @@
       </p:sp>
       <p:pic>
         <p:nvPicPr>
-          <p:cNvPr id="9" name="Picture 8">
-            <a:extLst>
-              <a:ext uri="{FF2B5EF4-FFF2-40B4-BE49-F238E27FC236}">
-                <a16:creationId xmlns:a16="http://schemas.microsoft.com/office/drawing/2014/main" id="{52E76584-269E-74FF-1CE8-1A46CF706B72}"/>
+          <p:cNvPr id="4" name="Picture 3">
+            <a:extLst>
+              <a:ext uri="{FF2B5EF4-FFF2-40B4-BE49-F238E27FC236}">
+                <a16:creationId xmlns:a16="http://schemas.microsoft.com/office/drawing/2014/main" id="{56F2B7C5-5C82-1EFC-24A8-71F0D651C867}"/>
               </a:ext>
             </a:extLst>
           </p:cNvPr>
@@ -5394,8 +5395,8 @@
         </p:blipFill>
         <p:spPr>
           <a:xfrm>
-            <a:off x="243906" y="1285875"/>
-            <a:ext cx="7948816" cy="4838700"/>
+            <a:off x="243907" y="1285875"/>
+            <a:ext cx="7948816" cy="4856904"/>
           </a:xfrm>
           <a:prstGeom prst="rect">
             <a:avLst/>
@@ -5411,6 +5412,179 @@
     <p:extLst>
       <p:ext uri="{BB962C8B-B14F-4D97-AF65-F5344CB8AC3E}">
         <p14:creationId xmlns:p14="http://schemas.microsoft.com/office/powerpoint/2010/main" val="538655942"/>
+      </p:ext>
+    </p:extLst>
+  </p:cSld>
+  <p:clrMapOvr>
+    <a:masterClrMapping/>
+  </p:clrMapOvr>
+</p:sld>
+</file>
+
+<file path=ppt/slides/slide14.xml><?xml version="1.0" encoding="utf-8"?>
+<p:sld xmlns:a="http://schemas.openxmlformats.org/drawingml/2006/main" xmlns:r="http://schemas.openxmlformats.org/officeDocument/2006/relationships" xmlns:p="http://schemas.openxmlformats.org/presentationml/2006/main">
+  <p:cSld>
+    <p:spTree>
+      <p:nvGrpSpPr>
+        <p:cNvPr id="1" name="">
+          <a:extLst>
+            <a:ext uri="{FF2B5EF4-FFF2-40B4-BE49-F238E27FC236}">
+              <a16:creationId xmlns:a16="http://schemas.microsoft.com/office/drawing/2014/main" id="{953554C3-04F3-F7CF-E541-8935FC269E25}"/>
+            </a:ext>
+          </a:extLst>
+        </p:cNvPr>
+        <p:cNvGrpSpPr/>
+        <p:nvPr/>
+      </p:nvGrpSpPr>
+      <p:grpSpPr>
+        <a:xfrm>
+          <a:off x="0" y="0"/>
+          <a:ext cx="0" cy="0"/>
+          <a:chOff x="0" y="0"/>
+          <a:chExt cx="0" cy="0"/>
+        </a:xfrm>
+      </p:grpSpPr>
+      <p:pic>
+        <p:nvPicPr>
+          <p:cNvPr id="8" name="Picture 7">
+            <a:extLst>
+              <a:ext uri="{FF2B5EF4-FFF2-40B4-BE49-F238E27FC236}">
+                <a16:creationId xmlns:a16="http://schemas.microsoft.com/office/drawing/2014/main" id="{C6215A35-5338-1E13-0EF3-27DABDDE13D3}"/>
+              </a:ext>
+            </a:extLst>
+          </p:cNvPr>
+          <p:cNvPicPr>
+            <a:picLocks noChangeAspect="1"/>
+          </p:cNvPicPr>
+          <p:nvPr/>
+        </p:nvPicPr>
+        <p:blipFill>
+          <a:blip r:embed="rId2"/>
+          <a:stretch>
+            <a:fillRect/>
+          </a:stretch>
+        </p:blipFill>
+        <p:spPr>
+          <a:xfrm>
+            <a:off x="243907" y="1285875"/>
+            <a:ext cx="7948816" cy="4850556"/>
+          </a:xfrm>
+          <a:prstGeom prst="rect">
+            <a:avLst/>
+          </a:prstGeom>
+          <a:ln>
+            <a:solidFill>
+              <a:schemeClr val="tx1"/>
+            </a:solidFill>
+          </a:ln>
+        </p:spPr>
+      </p:pic>
+      <p:sp>
+        <p:nvSpPr>
+          <p:cNvPr id="3" name="TextBox 2">
+            <a:extLst>
+              <a:ext uri="{FF2B5EF4-FFF2-40B4-BE49-F238E27FC236}">
+                <a16:creationId xmlns:a16="http://schemas.microsoft.com/office/drawing/2014/main" id="{C4F6CF00-620E-D538-3340-A82F881C25A3}"/>
+              </a:ext>
+            </a:extLst>
+          </p:cNvPr>
+          <p:cNvSpPr txBox="1"/>
+          <p:nvPr/>
+        </p:nvSpPr>
+        <p:spPr>
+          <a:xfrm>
+            <a:off x="124051" y="102889"/>
+            <a:ext cx="11607874" cy="369332"/>
+          </a:xfrm>
+          <a:prstGeom prst="rect">
+            <a:avLst/>
+          </a:prstGeom>
+          <a:noFill/>
+        </p:spPr>
+        <p:txBody>
+          <a:bodyPr wrap="square">
+            <a:spAutoFit/>
+          </a:bodyPr>
+          <a:lstStyle/>
+          <a:p>
+            <a:pPr marL="342900" indent="-342900">
+              <a:buFont typeface="+mj-lt"/>
+              <a:buAutoNum type="arabicPeriod" startAt="11"/>
+            </a:pPr>
+            <a:r>
+              <a:rPr lang="en-GB" dirty="0"/>
+              <a:t>Add driver for pump. Add </a:t>
+            </a:r>
+            <a:r>
+              <a:rPr lang="en-GB" dirty="0" err="1"/>
+              <a:t>VortexBreaker</a:t>
+            </a:r>
+            <a:r>
+              <a:rPr lang="en-GB" dirty="0"/>
+              <a:t> internal.</a:t>
+            </a:r>
+          </a:p>
+        </p:txBody>
+      </p:sp>
+      <p:sp>
+        <p:nvSpPr>
+          <p:cNvPr id="6" name="TextBox 5">
+            <a:extLst>
+              <a:ext uri="{FF2B5EF4-FFF2-40B4-BE49-F238E27FC236}">
+                <a16:creationId xmlns:a16="http://schemas.microsoft.com/office/drawing/2014/main" id="{B86BB71F-A940-4152-3C48-BC9CCCE2DC8E}"/>
+              </a:ext>
+            </a:extLst>
+          </p:cNvPr>
+          <p:cNvSpPr txBox="1"/>
+          <p:nvPr/>
+        </p:nvSpPr>
+        <p:spPr>
+          <a:xfrm>
+            <a:off x="8531794" y="1166068"/>
+            <a:ext cx="3416300" cy="646331"/>
+          </a:xfrm>
+          <a:prstGeom prst="rect">
+            <a:avLst/>
+          </a:prstGeom>
+          <a:noFill/>
+        </p:spPr>
+        <p:txBody>
+          <a:bodyPr wrap="square" rtlCol="0">
+            <a:spAutoFit/>
+          </a:bodyPr>
+          <a:lstStyle/>
+          <a:p>
+            <a:pPr marL="342900" indent="-342900">
+              <a:buAutoNum type="arabicPeriod"/>
+            </a:pPr>
+            <a:r>
+              <a:rPr lang="en-GB" dirty="0"/>
+              <a:t>Add pump driver.</a:t>
+            </a:r>
+          </a:p>
+          <a:p>
+            <a:pPr marL="342900" indent="-342900">
+              <a:buAutoNum type="arabicPeriod"/>
+            </a:pPr>
+            <a:r>
+              <a:rPr lang="en-GB" dirty="0"/>
+              <a:t>Add </a:t>
+            </a:r>
+            <a:r>
+              <a:rPr lang="en-GB" dirty="0" err="1"/>
+              <a:t>VortexBreaker</a:t>
+            </a:r>
+            <a:r>
+              <a:rPr lang="en-GB" dirty="0"/>
+              <a:t> internal</a:t>
+            </a:r>
+          </a:p>
+        </p:txBody>
+      </p:sp>
+    </p:spTree>
+    <p:extLst>
+      <p:ext uri="{BB962C8B-B14F-4D97-AF65-F5344CB8AC3E}">
+        <p14:creationId xmlns:p14="http://schemas.microsoft.com/office/powerpoint/2010/main" val="720805857"/>
       </p:ext>
     </p:extLst>
   </p:cSld>
@@ -5458,7 +5632,7 @@
         <p:spPr>
           <a:xfrm>
             <a:off x="419100" y="740122"/>
-            <a:ext cx="11216639" cy="5632311"/>
+            <a:ext cx="11216639" cy="1200329"/>
           </a:xfrm>
           <a:prstGeom prst="rect">
             <a:avLst/>
@@ -5473,231 +5647,20 @@
           <a:p>
             <a:pPr marL="342900" indent="-342900">
               <a:buFont typeface="+mj-lt"/>
-              <a:buAutoNum type="arabicPeriod"/>
+              <a:buAutoNum type="arabicPeriod" startAt="11"/>
             </a:pPr>
             <a:r>
               <a:rPr lang="en-GB" dirty="0"/>
-              <a:t>Base </a:t>
+              <a:t>Add driver for pump. Add </a:t>
             </a:r>
             <a:r>
               <a:rPr lang="en-GB" dirty="0" err="1"/>
-              <a:t>BluePrint</a:t>
+              <a:t>VortexBreaker</a:t>
             </a:r>
             <a:r>
               <a:rPr lang="en-GB" dirty="0"/>
-              <a:t> File</a:t>
-            </a:r>
-          </a:p>
-          <a:p>
-            <a:pPr marL="342900" indent="-342900">
-              <a:buFont typeface="+mj-lt"/>
-              <a:buAutoNum type="arabicPeriod" startAt="2"/>
-            </a:pPr>
-            <a:r>
-              <a:rPr lang="en-GB" dirty="0"/>
-              <a:t>Split DEXPI </a:t>
-            </a:r>
-            <a:r>
-              <a:rPr lang="en-GB" dirty="0" err="1"/>
-              <a:t>PipingNetworkSegment</a:t>
-            </a:r>
-            <a:r>
-              <a:rPr lang="en-GB" dirty="0"/>
-              <a:t> with a piping tee. E.g. split D-20L00004A DEXPI </a:t>
-            </a:r>
-            <a:r>
-              <a:rPr lang="en-GB" dirty="0" err="1"/>
-              <a:t>PipingNetworkSegment</a:t>
-            </a:r>
-            <a:r>
-              <a:rPr lang="en-GB" dirty="0"/>
-              <a:t> by placing a piping tee between the ESV0006 actuated valve and the FE0001 element and include an unnamed valve.</a:t>
-            </a:r>
-          </a:p>
-          <a:p>
-            <a:pPr marL="342900" indent="-342900">
-              <a:buFont typeface="+mj-lt"/>
-              <a:buAutoNum type="arabicPeriod" startAt="3"/>
-            </a:pPr>
-            <a:r>
-              <a:rPr lang="en-GB" dirty="0"/>
-              <a:t>Rename TI0003/TIC0003/TV0003 to TI0013/TIC0013/TV0013 and update associated loop.</a:t>
-            </a:r>
-          </a:p>
-          <a:p>
-            <a:pPr marL="800100" lvl="1" indent="-342900">
-              <a:buFont typeface="Arial" panose="020B0604020202020204" pitchFamily="34" charset="0"/>
-              <a:buChar char="•"/>
-            </a:pPr>
-            <a:r>
-              <a:rPr lang="en-GB" dirty="0"/>
-              <a:t>Retain the original </a:t>
-            </a:r>
-            <a:r>
-              <a:rPr lang="en-GB" dirty="0" err="1"/>
-              <a:t>PersistentID</a:t>
-            </a:r>
-            <a:r>
-              <a:rPr lang="en-GB" dirty="0"/>
-              <a:t> and change the name.</a:t>
-            </a:r>
-          </a:p>
-          <a:p>
-            <a:pPr marL="342900" indent="-342900">
-              <a:buFont typeface="+mj-lt"/>
-              <a:buAutoNum type="arabicPeriod" startAt="4"/>
-            </a:pPr>
-            <a:r>
-              <a:rPr lang="en-GB" dirty="0"/>
-              <a:t>Remove the note and unused nozzle from 20VA001 and update elevation to EL. 400000</a:t>
-            </a:r>
-          </a:p>
-          <a:p>
-            <a:pPr marL="342900" indent="-342900">
-              <a:buFont typeface="+mj-lt"/>
-              <a:buAutoNum type="arabicPeriod" startAt="5"/>
-            </a:pPr>
-            <a:r>
-              <a:rPr lang="en-GB" dirty="0"/>
-              <a:t>Change the type of actuator for HV0001 to a PA006A actuator type</a:t>
-            </a:r>
-          </a:p>
-          <a:p>
-            <a:pPr marL="800100" lvl="1" indent="-342900">
-              <a:buFont typeface="Arial" panose="020B0604020202020204" pitchFamily="34" charset="0"/>
-              <a:buChar char="•"/>
-            </a:pPr>
-            <a:r>
-              <a:rPr lang="en-GB" dirty="0"/>
-              <a:t>Retain </a:t>
-            </a:r>
-            <a:r>
-              <a:rPr lang="en-GB" dirty="0" err="1"/>
-              <a:t>PersistentID</a:t>
-            </a:r>
-            <a:r>
-              <a:rPr lang="en-GB" dirty="0"/>
-              <a:t> of original actuator</a:t>
-            </a:r>
-          </a:p>
-          <a:p>
-            <a:pPr marL="342900" indent="-342900">
-              <a:buFont typeface="+mj-lt"/>
-              <a:buAutoNum type="arabicPeriod" startAt="6"/>
-            </a:pPr>
-            <a:r>
-              <a:rPr lang="en-GB" dirty="0"/>
-              <a:t>Add heat tracing to </a:t>
-            </a:r>
-            <a:r>
-              <a:rPr lang="en-GB" dirty="0" err="1"/>
-              <a:t>PipingNetworkSegment</a:t>
-            </a:r>
-            <a:r>
-              <a:rPr lang="en-GB" dirty="0"/>
-              <a:t> D-20L A- PL-AS200-</a:t>
-            </a:r>
-          </a:p>
-          <a:p>
-            <a:pPr marL="800100" lvl="1" indent="-342900">
-              <a:buFont typeface="Arial" panose="020B0604020202020204" pitchFamily="34" charset="0"/>
-              <a:buChar char="•"/>
-            </a:pPr>
-            <a:r>
-              <a:rPr lang="en-GB" dirty="0"/>
-              <a:t>Modify the heat trace attribute on the segment</a:t>
-            </a:r>
-          </a:p>
-          <a:p>
-            <a:pPr marL="342900" indent="-342900">
-              <a:buFont typeface="+mj-lt"/>
-              <a:buAutoNum type="arabicPeriod" startAt="7"/>
-            </a:pPr>
-            <a:r>
-              <a:rPr lang="en-GB" dirty="0"/>
-              <a:t>Modify TI0007 combination -&gt; TW/TT combination with Special Item on </a:t>
-            </a:r>
-            <a:r>
-              <a:rPr lang="en-GB" dirty="0" err="1"/>
-              <a:t>PipingNetworkSegment</a:t>
-            </a:r>
-            <a:endParaRPr lang="en-GB" dirty="0"/>
-          </a:p>
-          <a:p>
-            <a:pPr marL="800100" lvl="1" indent="-342900">
-              <a:buFont typeface="Arial" panose="020B0604020202020204" pitchFamily="34" charset="0"/>
-              <a:buChar char="•"/>
-            </a:pPr>
-            <a:r>
-              <a:rPr lang="en-GB" dirty="0"/>
-              <a:t>** Use ND0037 ‘hidden’ in-line piping component to give location of special item.</a:t>
-            </a:r>
-          </a:p>
-          <a:p>
-            <a:pPr marL="342900" indent="-342900">
-              <a:buFont typeface="+mj-lt"/>
-              <a:buAutoNum type="arabicPeriod" startAt="8"/>
-            </a:pPr>
-            <a:r>
-              <a:rPr lang="en-GB" dirty="0"/>
-              <a:t>Additional property break at one of the break</a:t>
-            </a:r>
-          </a:p>
-          <a:p>
-            <a:pPr marL="742950" lvl="1" indent="-285750">
-              <a:buFont typeface="Arial" panose="020B0604020202020204" pitchFamily="34" charset="0"/>
-              <a:buChar char="•"/>
-            </a:pPr>
-            <a:r>
-              <a:rPr lang="en-GB" dirty="0"/>
-              <a:t>Add </a:t>
-            </a:r>
-            <a:r>
-              <a:rPr lang="en-GB" dirty="0" err="1"/>
-              <a:t>AreaBreak</a:t>
-            </a:r>
-            <a:r>
-              <a:rPr lang="en-GB" dirty="0"/>
-              <a:t> AP110 / AP310 need to associate these to the </a:t>
-            </a:r>
-            <a:r>
-              <a:rPr lang="en-GB" dirty="0" err="1"/>
-              <a:t>PipingNetworkSystems</a:t>
-            </a:r>
-            <a:endParaRPr lang="en-GB" dirty="0"/>
-          </a:p>
-          <a:p>
-            <a:pPr marL="342900" indent="-342900">
-              <a:buFont typeface="+mj-lt"/>
-              <a:buAutoNum type="arabicPeriod" startAt="9"/>
-            </a:pPr>
-            <a:r>
-              <a:rPr lang="en-GB" dirty="0"/>
-              <a:t>Scale D-20HA001 symbol y-axis scaling 1.25 </a:t>
-            </a:r>
-          </a:p>
-          <a:p>
-            <a:pPr marL="342900" indent="-342900">
-              <a:buFont typeface="+mj-lt"/>
-              <a:buAutoNum type="arabicPeriod" startAt="9"/>
-            </a:pPr>
-            <a:r>
-              <a:rPr lang="en-GB" dirty="0"/>
-              <a:t>Modify pipe lines: </a:t>
-            </a:r>
-            <a:r>
-              <a:rPr lang="en-GB" sz="1800" b="0" i="0" u="none" strike="noStrike" baseline="0" dirty="0"/>
-              <a:t>D-20L00005A-1200PL-AS200-   &amp; D-20L00015A-0800PL-AD750- to test </a:t>
-            </a:r>
-            <a:r>
-              <a:rPr lang="en-GB" sz="1800" b="0" i="0" u="none" strike="noStrike" baseline="0" dirty="0" err="1"/>
-              <a:t>PipingNetworkSegment</a:t>
-            </a:r>
-            <a:r>
-              <a:rPr lang="en-GB" sz="1800" b="0" i="0" u="none" strike="noStrike" baseline="0" dirty="0"/>
-              <a:t> export variants</a:t>
-            </a:r>
-            <a:endParaRPr lang="en-GB" dirty="0"/>
+              <a:t> internal.</a:t>
+            </a:r>
           </a:p>
           <a:p>
             <a:pPr marL="342900" indent="-342900">

</xml_diff>

<commit_message>
mod: symbol descriptions mod: use case slide for changes no. 10
</commit_message>
<xml_diff>
--- a/Blueprint/UseCases_PersistenID.pptx
+++ b/Blueprint/UseCases_PersistenID.pptx
@@ -993,7 +993,7 @@
           <a:p>
             <a:fld id="{29BFE5FB-EE99-4E69-B2F7-C156D52DE4BD}" type="datetimeFigureOut">
               <a:rPr lang="en-GB" smtClean="0"/>
-              <a:t>27/10/2025</a:t>
+              <a:t>28/10/2025</a:t>
             </a:fld>
             <a:endParaRPr lang="en-GB"/>
           </a:p>
@@ -1047,7 +1047,7 @@
           <a:p>
             <a:fld id="{3836AF56-0639-4F1D-BCB4-5CA5D280A9DE}" type="slidenum">
               <a:rPr lang="en-GB" smtClean="0"/>
-              <a:t>‹#›</a:t>
+              <a:t>‹Nr.›</a:t>
             </a:fld>
             <a:endParaRPr lang="en-GB"/>
           </a:p>
@@ -1193,7 +1193,7 @@
           <a:p>
             <a:fld id="{29BFE5FB-EE99-4E69-B2F7-C156D52DE4BD}" type="datetimeFigureOut">
               <a:rPr lang="en-GB" smtClean="0"/>
-              <a:t>27/10/2025</a:t>
+              <a:t>28/10/2025</a:t>
             </a:fld>
             <a:endParaRPr lang="en-GB"/>
           </a:p>
@@ -1247,7 +1247,7 @@
           <a:p>
             <a:fld id="{3836AF56-0639-4F1D-BCB4-5CA5D280A9DE}" type="slidenum">
               <a:rPr lang="en-GB" smtClean="0"/>
-              <a:t>‹#›</a:t>
+              <a:t>‹Nr.›</a:t>
             </a:fld>
             <a:endParaRPr lang="en-GB"/>
           </a:p>
@@ -1403,7 +1403,7 @@
           <a:p>
             <a:fld id="{29BFE5FB-EE99-4E69-B2F7-C156D52DE4BD}" type="datetimeFigureOut">
               <a:rPr lang="en-GB" smtClean="0"/>
-              <a:t>27/10/2025</a:t>
+              <a:t>28/10/2025</a:t>
             </a:fld>
             <a:endParaRPr lang="en-GB"/>
           </a:p>
@@ -1457,7 +1457,7 @@
           <a:p>
             <a:fld id="{3836AF56-0639-4F1D-BCB4-5CA5D280A9DE}" type="slidenum">
               <a:rPr lang="en-GB" smtClean="0"/>
-              <a:t>‹#›</a:t>
+              <a:t>‹Nr.›</a:t>
             </a:fld>
             <a:endParaRPr lang="en-GB"/>
           </a:p>
@@ -1603,7 +1603,7 @@
           <a:p>
             <a:fld id="{29BFE5FB-EE99-4E69-B2F7-C156D52DE4BD}" type="datetimeFigureOut">
               <a:rPr lang="en-GB" smtClean="0"/>
-              <a:t>27/10/2025</a:t>
+              <a:t>28/10/2025</a:t>
             </a:fld>
             <a:endParaRPr lang="en-GB"/>
           </a:p>
@@ -1657,7 +1657,7 @@
           <a:p>
             <a:fld id="{3836AF56-0639-4F1D-BCB4-5CA5D280A9DE}" type="slidenum">
               <a:rPr lang="en-GB" smtClean="0"/>
-              <a:t>‹#›</a:t>
+              <a:t>‹Nr.›</a:t>
             </a:fld>
             <a:endParaRPr lang="en-GB"/>
           </a:p>
@@ -1879,7 +1879,7 @@
           <a:p>
             <a:fld id="{29BFE5FB-EE99-4E69-B2F7-C156D52DE4BD}" type="datetimeFigureOut">
               <a:rPr lang="en-GB" smtClean="0"/>
-              <a:t>27/10/2025</a:t>
+              <a:t>28/10/2025</a:t>
             </a:fld>
             <a:endParaRPr lang="en-GB"/>
           </a:p>
@@ -1933,7 +1933,7 @@
           <a:p>
             <a:fld id="{3836AF56-0639-4F1D-BCB4-5CA5D280A9DE}" type="slidenum">
               <a:rPr lang="en-GB" smtClean="0"/>
-              <a:t>‹#›</a:t>
+              <a:t>‹Nr.›</a:t>
             </a:fld>
             <a:endParaRPr lang="en-GB"/>
           </a:p>
@@ -2147,7 +2147,7 @@
           <a:p>
             <a:fld id="{29BFE5FB-EE99-4E69-B2F7-C156D52DE4BD}" type="datetimeFigureOut">
               <a:rPr lang="en-GB" smtClean="0"/>
-              <a:t>27/10/2025</a:t>
+              <a:t>28/10/2025</a:t>
             </a:fld>
             <a:endParaRPr lang="en-GB"/>
           </a:p>
@@ -2201,7 +2201,7 @@
           <a:p>
             <a:fld id="{3836AF56-0639-4F1D-BCB4-5CA5D280A9DE}" type="slidenum">
               <a:rPr lang="en-GB" smtClean="0"/>
-              <a:t>‹#›</a:t>
+              <a:t>‹Nr.›</a:t>
             </a:fld>
             <a:endParaRPr lang="en-GB"/>
           </a:p>
@@ -2562,7 +2562,7 @@
           <a:p>
             <a:fld id="{29BFE5FB-EE99-4E69-B2F7-C156D52DE4BD}" type="datetimeFigureOut">
               <a:rPr lang="en-GB" smtClean="0"/>
-              <a:t>27/10/2025</a:t>
+              <a:t>28/10/2025</a:t>
             </a:fld>
             <a:endParaRPr lang="en-GB"/>
           </a:p>
@@ -2616,7 +2616,7 @@
           <a:p>
             <a:fld id="{3836AF56-0639-4F1D-BCB4-5CA5D280A9DE}" type="slidenum">
               <a:rPr lang="en-GB" smtClean="0"/>
-              <a:t>‹#›</a:t>
+              <a:t>‹Nr.›</a:t>
             </a:fld>
             <a:endParaRPr lang="en-GB"/>
           </a:p>
@@ -2704,7 +2704,7 @@
           <a:p>
             <a:fld id="{29BFE5FB-EE99-4E69-B2F7-C156D52DE4BD}" type="datetimeFigureOut">
               <a:rPr lang="en-GB" smtClean="0"/>
-              <a:t>27/10/2025</a:t>
+              <a:t>28/10/2025</a:t>
             </a:fld>
             <a:endParaRPr lang="en-GB"/>
           </a:p>
@@ -2758,7 +2758,7 @@
           <a:p>
             <a:fld id="{3836AF56-0639-4F1D-BCB4-5CA5D280A9DE}" type="slidenum">
               <a:rPr lang="en-GB" smtClean="0"/>
-              <a:t>‹#›</a:t>
+              <a:t>‹Nr.›</a:t>
             </a:fld>
             <a:endParaRPr lang="en-GB"/>
           </a:p>
@@ -2817,7 +2817,7 @@
           <a:p>
             <a:fld id="{29BFE5FB-EE99-4E69-B2F7-C156D52DE4BD}" type="datetimeFigureOut">
               <a:rPr lang="en-GB" smtClean="0"/>
-              <a:t>27/10/2025</a:t>
+              <a:t>28/10/2025</a:t>
             </a:fld>
             <a:endParaRPr lang="en-GB"/>
           </a:p>
@@ -2871,7 +2871,7 @@
           <a:p>
             <a:fld id="{3836AF56-0639-4F1D-BCB4-5CA5D280A9DE}" type="slidenum">
               <a:rPr lang="en-GB" smtClean="0"/>
-              <a:t>‹#›</a:t>
+              <a:t>‹Nr.›</a:t>
             </a:fld>
             <a:endParaRPr lang="en-GB"/>
           </a:p>
@@ -3130,7 +3130,7 @@
           <a:p>
             <a:fld id="{29BFE5FB-EE99-4E69-B2F7-C156D52DE4BD}" type="datetimeFigureOut">
               <a:rPr lang="en-GB" smtClean="0"/>
-              <a:t>27/10/2025</a:t>
+              <a:t>28/10/2025</a:t>
             </a:fld>
             <a:endParaRPr lang="en-GB"/>
           </a:p>
@@ -3184,7 +3184,7 @@
           <a:p>
             <a:fld id="{3836AF56-0639-4F1D-BCB4-5CA5D280A9DE}" type="slidenum">
               <a:rPr lang="en-GB" smtClean="0"/>
-              <a:t>‹#›</a:t>
+              <a:t>‹Nr.›</a:t>
             </a:fld>
             <a:endParaRPr lang="en-GB"/>
           </a:p>
@@ -3419,7 +3419,7 @@
           <a:p>
             <a:fld id="{29BFE5FB-EE99-4E69-B2F7-C156D52DE4BD}" type="datetimeFigureOut">
               <a:rPr lang="en-GB" smtClean="0"/>
-              <a:t>27/10/2025</a:t>
+              <a:t>28/10/2025</a:t>
             </a:fld>
             <a:endParaRPr lang="en-GB"/>
           </a:p>
@@ -3473,7 +3473,7 @@
           <a:p>
             <a:fld id="{3836AF56-0639-4F1D-BCB4-5CA5D280A9DE}" type="slidenum">
               <a:rPr lang="en-GB" smtClean="0"/>
-              <a:t>‹#›</a:t>
+              <a:t>‹Nr.›</a:t>
             </a:fld>
             <a:endParaRPr lang="en-GB"/>
           </a:p>
@@ -3662,7 +3662,7 @@
           <a:p>
             <a:fld id="{29BFE5FB-EE99-4E69-B2F7-C156D52DE4BD}" type="datetimeFigureOut">
               <a:rPr lang="en-GB" smtClean="0"/>
-              <a:t>27/10/2025</a:t>
+              <a:t>28/10/2025</a:t>
             </a:fld>
             <a:endParaRPr lang="en-GB"/>
           </a:p>
@@ -3752,7 +3752,7 @@
           <a:p>
             <a:fld id="{3836AF56-0639-4F1D-BCB4-5CA5D280A9DE}" type="slidenum">
               <a:rPr lang="en-GB" smtClean="0"/>
-              <a:t>‹#›</a:t>
+              <a:t>‹Nr.›</a:t>
             </a:fld>
             <a:endParaRPr lang="en-GB"/>
           </a:p>
@@ -5213,7 +5213,7 @@
         <p:spPr>
           <a:xfrm>
             <a:off x="8531794" y="1166068"/>
-            <a:ext cx="3416300" cy="3693319"/>
+            <a:ext cx="3416300" cy="4247317"/>
           </a:xfrm>
           <a:prstGeom prst="rect">
             <a:avLst/>
@@ -5260,6 +5260,15 @@
             <a:pPr marL="342900" indent="-342900">
               <a:buAutoNum type="arabicPeriod"/>
             </a:pPr>
+            <a:r>
+              <a:rPr lang="en-GB" dirty="0"/>
+              <a:t>Add ball valve D-VB20-0005</a:t>
+            </a:r>
+          </a:p>
+          <a:p>
+            <a:pPr marL="342900" indent="-342900">
+              <a:buAutoNum type="arabicPeriod"/>
+            </a:pPr>
             <a:endParaRPr lang="en-GB" dirty="0"/>
           </a:p>
           <a:p>
@@ -5273,7 +5282,7 @@
             </a:r>
             <a:r>
               <a:rPr lang="en-GB" dirty="0"/>
-              <a:t> will be created either side of the ball valve that is part of the main line.</a:t>
+              <a:t> will be created either side of the ball valve D-VB20-0002 that is part of the main line.</a:t>
             </a:r>
           </a:p>
         </p:txBody>

</xml_diff>